<commit_message>
chore(p1): keep the P1 commits to the deploy and docs change set
`docs/3rdPartyAS_Poc_Introduction.pptx` was already staged in the working
tree (the presentation is open in an editor) when the P1 commits were
created, so the plain `git commit` carried that staged binary into
b5ad287. This restores the committed deck to its previous revision. The
working-tree copy is put back unchanged afterwards, so the in-progress edit
is not lost and stays exactly as the author left it.
</commit_message>
<xml_diff>
--- a/docs/3rdPartyAS_Poc_Introduction.pptx
+++ b/docs/3rdPartyAS_Poc_Introduction.pptx
@@ -262,7 +262,7 @@
   <p:extLst>
     <p:ext uri="{EFAFB233-063F-42B5-8137-9DF3F51BA10A}">
       <p15:sldGuideLst xmlns:p15="http://schemas.microsoft.com/office/powerpoint/2012/main">
-        <p15:guide id="1" orient="horz" pos="1624" userDrawn="1">
+        <p15:guide id="1" orient="horz" pos="1640" userDrawn="1">
           <p15:clr>
             <a:srgbClr val="747775"/>
           </p15:clr>
@@ -17801,7 +17801,7 @@
         </p:nvSpPr>
         <p:spPr>
           <a:xfrm>
-            <a:off x="1016000" y="5292090"/>
+            <a:off x="1016000" y="4699000"/>
             <a:ext cx="10160000" cy="304800"/>
           </a:xfrm>
           <a:prstGeom prst="rect">
@@ -17837,72 +17837,6 @@
               <a:t>September 2026</a:t>
             </a:r>
             <a:endParaRPr lang="en-US" sz="1100"/>
-          </a:p>
-        </p:txBody>
-      </p:sp>
-      <p:sp>
-        <p:nvSpPr>
-          <p:cNvPr id="8" name="AutoShape 7"/>
-          <p:cNvSpPr/>
-          <p:nvPr/>
-        </p:nvSpPr>
-        <p:spPr>
-          <a:xfrm>
-            <a:off x="1016000" y="4883150"/>
-            <a:ext cx="10160000" cy="304800"/>
-          </a:xfrm>
-          <a:prstGeom prst="rect">
-            <a:avLst/>
-          </a:prstGeom>
-          <a:noFill/>
-          <a:ln w="12700" cap="flat" cmpd="sng">
-            <a:noFill/>
-            <a:prstDash val="solid"/>
-            <a:round/>
-          </a:ln>
-        </p:spPr>
-        <p:txBody>
-          <a:bodyPr vert="horz" wrap="square" lIns="0" tIns="0" rIns="0" bIns="0" rtlCol="0" anchor="ctr" anchorCtr="0"/>
-          <a:p>
-            <a:pPr marL="0" indent="0" algn="l">
-              <a:lnSpc>
-                <a:spcPct val="125000"/>
-              </a:lnSpc>
-              <a:defRPr/>
-            </a:pPr>
-            <a:r>
-              <a:rPr lang="en-US" sz="1400" b="0" i="0" u="none" strike="noStrike">
-                <a:solidFill>
-                  <a:srgbClr val="BFD7FF"/>
-                </a:solidFill>
-                <a:latin typeface="Inter"/>
-                <a:ea typeface="Inter"/>
-                <a:cs typeface="Inter"/>
-                <a:sym typeface="Inter"/>
-              </a:rPr>
-              <a:t>Dolan </a:t>
-            </a:r>
-            <a:r>
-              <a:rPr lang="en-US" sz="1400" b="0" i="0" u="none" strike="noStrike">
-                <a:solidFill>
-                  <a:srgbClr val="BFD7FF"/>
-                </a:solidFill>
-                <a:latin typeface="Inter"/>
-                <a:ea typeface="Inter"/>
-                <a:cs typeface="Inter"/>
-                <a:sym typeface="Inter"/>
-              </a:rPr>
-              <a:t>Shu</a:t>
-            </a:r>
-            <a:endParaRPr lang="en-US" sz="1400" b="0" i="0" u="none" strike="noStrike">
-              <a:solidFill>
-                <a:srgbClr val="BFD7FF"/>
-              </a:solidFill>
-              <a:latin typeface="Inter"/>
-              <a:ea typeface="Inter"/>
-              <a:cs typeface="Inter"/>
-              <a:sym typeface="Inter"/>
-            </a:endParaRPr>
           </a:p>
         </p:txBody>
       </p:sp>

</xml_diff>